<commit_message>
update the acritecture presentation
</commit_message>
<xml_diff>
--- a/docs/מצגת ארכיטקטורה.pptx
+++ b/docs/מצגת ארכיטקטורה.pptx
@@ -111,6 +111,11 @@
       </a:defRPr>
     </a:lvl9pPr>
   </p:defaultTextStyle>
+  <p:extLst>
+    <p:ext uri="{EFAFB233-063F-42B5-8137-9DF3F51BA10A}">
+      <p15:sldGuideLst xmlns:p15="http://schemas.microsoft.com/office/powerpoint/2012/main"/>
+    </p:ext>
+  </p:extLst>
 </p:presentation>
 </file>
 
@@ -261,7 +266,7 @@
           <a:p>
             <a:fld id="{4924AB14-111D-4F39-82DE-A7D846276989}" type="datetimeFigureOut">
               <a:rPr lang="he-IL" smtClean="0"/>
-              <a:t>ט'/אלול/תשפ"ו</a:t>
+              <a:t>י'/אלול/תשפ"ו</a:t>
             </a:fld>
             <a:endParaRPr lang="he-IL"/>
           </a:p>
@@ -459,7 +464,7 @@
           <a:p>
             <a:fld id="{4924AB14-111D-4F39-82DE-A7D846276989}" type="datetimeFigureOut">
               <a:rPr lang="he-IL" smtClean="0"/>
-              <a:t>ט'/אלול/תשפ"ו</a:t>
+              <a:t>י'/אלול/תשפ"ו</a:t>
             </a:fld>
             <a:endParaRPr lang="he-IL"/>
           </a:p>
@@ -667,7 +672,7 @@
           <a:p>
             <a:fld id="{4924AB14-111D-4F39-82DE-A7D846276989}" type="datetimeFigureOut">
               <a:rPr lang="he-IL" smtClean="0"/>
-              <a:t>ט'/אלול/תשפ"ו</a:t>
+              <a:t>י'/אלול/תשפ"ו</a:t>
             </a:fld>
             <a:endParaRPr lang="he-IL"/>
           </a:p>
@@ -865,7 +870,7 @@
           <a:p>
             <a:fld id="{4924AB14-111D-4F39-82DE-A7D846276989}" type="datetimeFigureOut">
               <a:rPr lang="he-IL" smtClean="0"/>
-              <a:t>ט'/אלול/תשפ"ו</a:t>
+              <a:t>י'/אלול/תשפ"ו</a:t>
             </a:fld>
             <a:endParaRPr lang="he-IL"/>
           </a:p>
@@ -1140,7 +1145,7 @@
           <a:p>
             <a:fld id="{4924AB14-111D-4F39-82DE-A7D846276989}" type="datetimeFigureOut">
               <a:rPr lang="he-IL" smtClean="0"/>
-              <a:t>ט'/אלול/תשפ"ו</a:t>
+              <a:t>י'/אלול/תשפ"ו</a:t>
             </a:fld>
             <a:endParaRPr lang="he-IL"/>
           </a:p>
@@ -1405,7 +1410,7 @@
           <a:p>
             <a:fld id="{4924AB14-111D-4F39-82DE-A7D846276989}" type="datetimeFigureOut">
               <a:rPr lang="he-IL" smtClean="0"/>
-              <a:t>ט'/אלול/תשפ"ו</a:t>
+              <a:t>י'/אלול/תשפ"ו</a:t>
             </a:fld>
             <a:endParaRPr lang="he-IL"/>
           </a:p>
@@ -1817,7 +1822,7 @@
           <a:p>
             <a:fld id="{4924AB14-111D-4F39-82DE-A7D846276989}" type="datetimeFigureOut">
               <a:rPr lang="he-IL" smtClean="0"/>
-              <a:t>ט'/אלול/תשפ"ו</a:t>
+              <a:t>י'/אלול/תשפ"ו</a:t>
             </a:fld>
             <a:endParaRPr lang="he-IL"/>
           </a:p>
@@ -1958,7 +1963,7 @@
           <a:p>
             <a:fld id="{4924AB14-111D-4F39-82DE-A7D846276989}" type="datetimeFigureOut">
               <a:rPr lang="he-IL" smtClean="0"/>
-              <a:t>ט'/אלול/תשפ"ו</a:t>
+              <a:t>י'/אלול/תשפ"ו</a:t>
             </a:fld>
             <a:endParaRPr lang="he-IL"/>
           </a:p>
@@ -2071,7 +2076,7 @@
           <a:p>
             <a:fld id="{4924AB14-111D-4F39-82DE-A7D846276989}" type="datetimeFigureOut">
               <a:rPr lang="he-IL" smtClean="0"/>
-              <a:t>ט'/אלול/תשפ"ו</a:t>
+              <a:t>י'/אלול/תשפ"ו</a:t>
             </a:fld>
             <a:endParaRPr lang="he-IL"/>
           </a:p>
@@ -2382,7 +2387,7 @@
           <a:p>
             <a:fld id="{4924AB14-111D-4F39-82DE-A7D846276989}" type="datetimeFigureOut">
               <a:rPr lang="he-IL" smtClean="0"/>
-              <a:t>ט'/אלול/תשפ"ו</a:t>
+              <a:t>י'/אלול/תשפ"ו</a:t>
             </a:fld>
             <a:endParaRPr lang="he-IL"/>
           </a:p>
@@ -2670,7 +2675,7 @@
           <a:p>
             <a:fld id="{4924AB14-111D-4F39-82DE-A7D846276989}" type="datetimeFigureOut">
               <a:rPr lang="he-IL" smtClean="0"/>
-              <a:t>ט'/אלול/תשפ"ו</a:t>
+              <a:t>י'/אלול/תשפ"ו</a:t>
             </a:fld>
             <a:endParaRPr lang="he-IL"/>
           </a:p>
@@ -2911,7 +2916,7 @@
           <a:p>
             <a:fld id="{4924AB14-111D-4F39-82DE-A7D846276989}" type="datetimeFigureOut">
               <a:rPr lang="he-IL" smtClean="0"/>
-              <a:t>ט'/אלול/תשפ"ו</a:t>
+              <a:t>י'/אלול/תשפ"ו</a:t>
             </a:fld>
             <a:endParaRPr lang="he-IL"/>
           </a:p>
@@ -3536,13 +3541,13 @@
   <p:clrMapOvr>
     <a:masterClrMapping/>
   </p:clrMapOvr>
-  <mc:AlternateContent xmlns:mc="http://schemas.openxmlformats.org/markup-compatibility/2006">
-    <mc:Choice xmlns:p159="http://schemas.microsoft.com/office/powerpoint/2015/09/main" Requires="p159">
+  <mc:AlternateContent xmlns:mc="http://schemas.openxmlformats.org/markup-compatibility/2006" xmlns:p159="http://schemas.microsoft.com/office/powerpoint/2015/09/main">
+    <mc:Choice Requires="p159">
       <p:transition xmlns:p14="http://schemas.microsoft.com/office/powerpoint/2010/main" spd="slow" p14:dur="2000">
         <p159:morph option="byObject"/>
       </p:transition>
     </mc:Choice>
-    <mc:Fallback>
+    <mc:Fallback xmlns="">
       <p:transition spd="slow">
         <p:fade/>
       </p:transition>
@@ -3876,13 +3881,13 @@
   <p:clrMapOvr>
     <a:masterClrMapping/>
   </p:clrMapOvr>
-  <mc:AlternateContent xmlns:mc="http://schemas.openxmlformats.org/markup-compatibility/2006">
-    <mc:Choice xmlns:p159="http://schemas.microsoft.com/office/powerpoint/2015/09/main" Requires="p159">
+  <mc:AlternateContent xmlns:mc="http://schemas.openxmlformats.org/markup-compatibility/2006" xmlns:p159="http://schemas.microsoft.com/office/powerpoint/2015/09/main">
+    <mc:Choice Requires="p159">
       <p:transition xmlns:p14="http://schemas.microsoft.com/office/powerpoint/2010/main" spd="slow" p14:dur="2000">
         <p159:morph option="byObject"/>
       </p:transition>
     </mc:Choice>
-    <mc:Fallback>
+    <mc:Fallback xmlns="">
       <p:transition spd="slow">
         <p:fade/>
       </p:transition>
@@ -4564,13 +4569,13 @@
   <p:clrMapOvr>
     <a:masterClrMapping/>
   </p:clrMapOvr>
-  <mc:AlternateContent xmlns:mc="http://schemas.openxmlformats.org/markup-compatibility/2006">
-    <mc:Choice xmlns:p159="http://schemas.microsoft.com/office/powerpoint/2015/09/main" Requires="p159">
+  <mc:AlternateContent xmlns:mc="http://schemas.openxmlformats.org/markup-compatibility/2006" xmlns:p159="http://schemas.microsoft.com/office/powerpoint/2015/09/main">
+    <mc:Choice Requires="p159">
       <p:transition xmlns:p14="http://schemas.microsoft.com/office/powerpoint/2010/main" spd="slow" p14:dur="2000">
         <p159:morph option="byObject"/>
       </p:transition>
     </mc:Choice>
-    <mc:Fallback>
+    <mc:Fallback xmlns="">
       <p:transition spd="slow">
         <p:fade/>
       </p:transition>
@@ -5569,13 +5574,13 @@
   <p:clrMapOvr>
     <a:masterClrMapping/>
   </p:clrMapOvr>
-  <mc:AlternateContent xmlns:mc="http://schemas.openxmlformats.org/markup-compatibility/2006">
-    <mc:Choice xmlns:p159="http://schemas.microsoft.com/office/powerpoint/2015/09/main" Requires="p159">
+  <mc:AlternateContent xmlns:mc="http://schemas.openxmlformats.org/markup-compatibility/2006" xmlns:p159="http://schemas.microsoft.com/office/powerpoint/2015/09/main">
+    <mc:Choice Requires="p159">
       <p:transition xmlns:p14="http://schemas.microsoft.com/office/powerpoint/2010/main" spd="slow" p14:dur="2000">
         <p159:morph option="byObject"/>
       </p:transition>
     </mc:Choice>
-    <mc:Fallback>
+    <mc:Fallback xmlns="">
       <p:transition spd="slow">
         <p:fade/>
       </p:transition>
@@ -6102,6 +6107,20 @@
               <a:t>פלט מצופה בסיום מוצלח</a:t>
             </a:r>
           </a:p>
+          <a:p>
+            <a:pPr marL="285750" indent="-285750">
+              <a:buFont typeface="Arial" panose="020B0604020202020204" pitchFamily="34" charset="0"/>
+              <a:buChar char="•"/>
+            </a:pPr>
+            <a:r>
+              <a:rPr lang="he-IL" sz="2400" dirty="0">
+                <a:solidFill>
+                  <a:schemeClr val="tx1"/>
+                </a:solidFill>
+              </a:rPr>
+              <a:t>האם הפעלה דורשת אישור מפקד.</a:t>
+            </a:r>
+          </a:p>
         </p:txBody>
       </p:sp>
       <p:cxnSp>
@@ -6283,13 +6302,13 @@
   <p:clrMapOvr>
     <a:masterClrMapping/>
   </p:clrMapOvr>
-  <mc:AlternateContent xmlns:mc="http://schemas.openxmlformats.org/markup-compatibility/2006">
-    <mc:Choice xmlns:p159="http://schemas.microsoft.com/office/powerpoint/2015/09/main" Requires="p159">
+  <mc:AlternateContent xmlns:mc="http://schemas.openxmlformats.org/markup-compatibility/2006" xmlns:p159="http://schemas.microsoft.com/office/powerpoint/2015/09/main">
+    <mc:Choice Requires="p159">
       <p:transition xmlns:p14="http://schemas.microsoft.com/office/powerpoint/2010/main" spd="slow" p14:dur="2000">
         <p159:morph option="byObject"/>
       </p:transition>
     </mc:Choice>
-    <mc:Fallback>
+    <mc:Fallback xmlns="">
       <p:transition spd="slow">
         <p:fade/>
       </p:transition>
@@ -6778,13 +6797,13 @@
   <p:clrMapOvr>
     <a:masterClrMapping/>
   </p:clrMapOvr>
-  <mc:AlternateContent xmlns:mc="http://schemas.openxmlformats.org/markup-compatibility/2006">
-    <mc:Choice xmlns:p159="http://schemas.microsoft.com/office/powerpoint/2015/09/main" Requires="p159">
+  <mc:AlternateContent xmlns:mc="http://schemas.openxmlformats.org/markup-compatibility/2006" xmlns:p159="http://schemas.microsoft.com/office/powerpoint/2015/09/main">
+    <mc:Choice Requires="p159">
       <p:transition xmlns:p14="http://schemas.microsoft.com/office/powerpoint/2010/main" spd="slow" p14:dur="2000">
         <p159:morph option="byObject"/>
       </p:transition>
     </mc:Choice>
-    <mc:Fallback>
+    <mc:Fallback xmlns="">
       <p:transition spd="slow">
         <p:fade/>
       </p:transition>
@@ -7522,13 +7541,13 @@
   <p:clrMapOvr>
     <a:masterClrMapping/>
   </p:clrMapOvr>
-  <mc:AlternateContent xmlns:mc="http://schemas.openxmlformats.org/markup-compatibility/2006">
-    <mc:Choice xmlns:p159="http://schemas.microsoft.com/office/powerpoint/2015/09/main" Requires="p159">
+  <mc:AlternateContent xmlns:mc="http://schemas.openxmlformats.org/markup-compatibility/2006" xmlns:p159="http://schemas.microsoft.com/office/powerpoint/2015/09/main">
+    <mc:Choice Requires="p159">
       <p:transition xmlns:p14="http://schemas.microsoft.com/office/powerpoint/2010/main" spd="slow" p14:dur="2000">
         <p159:morph option="byObject"/>
       </p:transition>
     </mc:Choice>
-    <mc:Fallback>
+    <mc:Fallback xmlns="">
       <p:transition spd="slow">
         <p:fade/>
       </p:transition>
@@ -7804,13 +7823,13 @@
   <p:clrMapOvr>
     <a:masterClrMapping/>
   </p:clrMapOvr>
-  <mc:AlternateContent xmlns:mc="http://schemas.openxmlformats.org/markup-compatibility/2006">
-    <mc:Choice xmlns:p159="http://schemas.microsoft.com/office/powerpoint/2015/09/main" Requires="p159">
+  <mc:AlternateContent xmlns:mc="http://schemas.openxmlformats.org/markup-compatibility/2006" xmlns:p159="http://schemas.microsoft.com/office/powerpoint/2015/09/main">
+    <mc:Choice Requires="p159">
       <p:transition xmlns:p14="http://schemas.microsoft.com/office/powerpoint/2010/main" spd="slow" p14:dur="2000">
         <p159:morph option="byObject"/>
       </p:transition>
     </mc:Choice>
-    <mc:Fallback>
+    <mc:Fallback xmlns="">
       <p:transition spd="slow">
         <p:fade/>
       </p:transition>

</xml_diff>